<commit_message>
Load base op cases from directory
Signed-off-by: jasonqinzhou <jasonqinzhou@users.noreply.github.com>
</commit_message>
<xml_diff>
--- a/docs/pr1113_collector_v2_slides.pptx
+++ b/docs/pr1113_collector_v2_slides.pptx
@@ -9918,23 +9918,6 @@
                 <a:ea typeface="Aptos Mono" pitchFamily="34" charset="-122"/>
                 <a:cs typeface="Aptos Mono" pitchFamily="34" charset="-120"/>
               </a:rPr>
-              <a:t>    base_op_cases.yaml</a:t>
-            </a:r>
-            <a:endParaRPr lang="en-US" sz="1100" dirty="0"/>
-          </a:p>
-          <a:p>
-            <a:pPr indent="0" marL="0">
-              <a:buNone/>
-            </a:pPr>
-            <a:r>
-              <a:rPr lang="en-US" sz="1100" dirty="0">
-                <a:solidFill>
-                  <a:srgbClr val="334155"/>
-                </a:solidFill>
-                <a:latin typeface="Aptos Mono" pitchFamily="34" charset="0"/>
-                <a:ea typeface="Aptos Mono" pitchFamily="34" charset="-122"/>
-                <a:cs typeface="Aptos Mono" pitchFamily="34" charset="-120"/>
-              </a:rPr>
               <a:t>    base_ops/&lt;op&gt;.yaml</a:t>
             </a:r>
             <a:endParaRPr lang="en-US" sz="1100" dirty="0"/>

</xml_diff>